<commit_message>
Add a HDF5 tool / vis slide
</commit_message>
<xml_diff>
--- a/22_September_Tuesday/04_morning_sources_detectors/Sources_Monitors/McStas_McXtrace_Sources_and_Monitors.pptx
+++ b/22_September_Tuesday/04_morning_sources_detectors/Sources_Monitors/McStas_McXtrace_Sources_and_Monitors.pptx
@@ -8789,8 +8789,180 @@
         </p:blipFill>
         <p:spPr>
           <a:xfrm>
-            <a:off x="155532" y="215702"/>
-            <a:ext cx="7772400" cy="6426595"/>
+            <a:off x="0" y="937546"/>
+            <a:ext cx="5389750" cy="4456505"/>
+          </a:xfrm>
+          <a:prstGeom prst="rect">
+            <a:avLst/>
+          </a:prstGeom>
+        </p:spPr>
+      </p:pic>
+      <p:pic>
+        <p:nvPicPr>
+          <p:cNvPr id="3" name="Picture 2">
+            <a:extLst>
+              <a:ext uri="{FF2B5EF4-FFF2-40B4-BE49-F238E27FC236}">
+                <a16:creationId xmlns:a16="http://schemas.microsoft.com/office/drawing/2014/main" id="{7E62DC19-F805-60B5-4771-C154DD682C62}"/>
+              </a:ext>
+            </a:extLst>
+          </p:cNvPr>
+          <p:cNvPicPr>
+            <a:picLocks noChangeAspect="1"/>
+          </p:cNvPicPr>
+          <p:nvPr/>
+        </p:nvPicPr>
+        <p:blipFill>
+          <a:blip r:embed="rId3"/>
+          <a:stretch>
+            <a:fillRect/>
+          </a:stretch>
+        </p:blipFill>
+        <p:spPr>
+          <a:xfrm>
+            <a:off x="5221266" y="813524"/>
+            <a:ext cx="6970734" cy="4704547"/>
+          </a:xfrm>
+          <a:prstGeom prst="rect">
+            <a:avLst/>
+          </a:prstGeom>
+        </p:spPr>
+      </p:pic>
+      <p:sp>
+        <p:nvSpPr>
+          <p:cNvPr id="5" name="Text 1">
+            <a:extLst>
+              <a:ext uri="{FF2B5EF4-FFF2-40B4-BE49-F238E27FC236}">
+                <a16:creationId xmlns:a16="http://schemas.microsoft.com/office/drawing/2014/main" id="{3955DFF4-64AC-5E43-1BC1-00EFF31594D2}"/>
+              </a:ext>
+            </a:extLst>
+          </p:cNvPr>
+          <p:cNvSpPr/>
+          <p:nvPr/>
+        </p:nvSpPr>
+        <p:spPr>
+          <a:xfrm>
+            <a:off x="322450" y="5508974"/>
+            <a:ext cx="1747650" cy="822960"/>
+          </a:xfrm>
+          <a:prstGeom prst="rect">
+            <a:avLst/>
+          </a:prstGeom>
+          <a:noFill/>
+          <a:ln/>
+        </p:spPr>
+        <p:txBody>
+          <a:bodyPr wrap="square" rtlCol="0" anchor="ctr"/>
+          <a:lstStyle/>
+          <a:p>
+            <a:pPr marL="0" indent="0" algn="l">
+              <a:buNone/>
+            </a:pPr>
+            <a:r>
+              <a:rPr lang="en-US" sz="3000" b="1" dirty="0" err="1">
+                <a:solidFill>
+                  <a:srgbClr val="20242B"/>
+                </a:solidFill>
+                <a:latin typeface="Cambria" pitchFamily="34" charset="0"/>
+                <a:ea typeface="Cambria" pitchFamily="34" charset="-122"/>
+                <a:cs typeface="Cambria" pitchFamily="34" charset="-120"/>
+              </a:rPr>
+              <a:t>NeXpy</a:t>
+            </a:r>
+            <a:endParaRPr lang="en-US" sz="3000" dirty="0"/>
+          </a:p>
+        </p:txBody>
+      </p:sp>
+      <p:sp>
+        <p:nvSpPr>
+          <p:cNvPr id="6" name="Text 1">
+            <a:extLst>
+              <a:ext uri="{FF2B5EF4-FFF2-40B4-BE49-F238E27FC236}">
+                <a16:creationId xmlns:a16="http://schemas.microsoft.com/office/drawing/2014/main" id="{E1ADA28D-A9A8-728C-8CCC-8CAB04CE7FE7}"/>
+              </a:ext>
+            </a:extLst>
+          </p:cNvPr>
+          <p:cNvSpPr/>
+          <p:nvPr/>
+        </p:nvSpPr>
+        <p:spPr>
+          <a:xfrm>
+            <a:off x="616202" y="114586"/>
+            <a:ext cx="9601200" cy="822960"/>
+          </a:xfrm>
+          <a:prstGeom prst="rect">
+            <a:avLst/>
+          </a:prstGeom>
+          <a:noFill/>
+          <a:ln/>
+        </p:spPr>
+        <p:txBody>
+          <a:bodyPr wrap="square" rtlCol="0" anchor="ctr"/>
+          <a:lstStyle/>
+          <a:p>
+            <a:pPr marL="0" indent="0" algn="l">
+              <a:buNone/>
+            </a:pPr>
+            <a:r>
+              <a:rPr lang="en-US" sz="3000" b="1" dirty="0">
+                <a:solidFill>
+                  <a:srgbClr val="20242B"/>
+                </a:solidFill>
+                <a:latin typeface="Cambria" pitchFamily="34" charset="0"/>
+                <a:ea typeface="Cambria" pitchFamily="34" charset="-122"/>
+                <a:cs typeface="Cambria" pitchFamily="34" charset="-120"/>
+              </a:rPr>
+              <a:t>Lightweight HDF5/</a:t>
+            </a:r>
+            <a:r>
+              <a:rPr lang="en-US" sz="3000" b="1" dirty="0" err="1">
+                <a:solidFill>
+                  <a:srgbClr val="20242B"/>
+                </a:solidFill>
+                <a:latin typeface="Cambria" pitchFamily="34" charset="0"/>
+                <a:ea typeface="Cambria" pitchFamily="34" charset="-122"/>
+                <a:cs typeface="Cambria" pitchFamily="34" charset="-120"/>
+              </a:rPr>
+              <a:t>NeXus</a:t>
+            </a:r>
+            <a:r>
+              <a:rPr lang="en-US" sz="3000" b="1" dirty="0">
+                <a:solidFill>
+                  <a:srgbClr val="20242B"/>
+                </a:solidFill>
+                <a:latin typeface="Cambria" pitchFamily="34" charset="0"/>
+                <a:ea typeface="Cambria" pitchFamily="34" charset="-122"/>
+                <a:cs typeface="Cambria" pitchFamily="34" charset="-120"/>
+              </a:rPr>
+              <a:t> plotting, fits etc.</a:t>
+            </a:r>
+            <a:endParaRPr lang="en-US" sz="3000" dirty="0"/>
+          </a:p>
+        </p:txBody>
+      </p:sp>
+      <p:pic>
+        <p:nvPicPr>
+          <p:cNvPr id="7" name="Picture 6" descr="silx logo">
+            <a:extLst>
+              <a:ext uri="{FF2B5EF4-FFF2-40B4-BE49-F238E27FC236}">
+                <a16:creationId xmlns:a16="http://schemas.microsoft.com/office/drawing/2014/main" id="{D22D1C5D-FC98-68FF-A3F7-886BA21085E5}"/>
+              </a:ext>
+            </a:extLst>
+          </p:cNvPr>
+          <p:cNvPicPr>
+            <a:picLocks noChangeAspect="1"/>
+          </p:cNvPicPr>
+          <p:nvPr/>
+        </p:nvPicPr>
+        <p:blipFill>
+          <a:blip r:embed="rId4"/>
+          <a:stretch>
+            <a:fillRect/>
+          </a:stretch>
+        </p:blipFill>
+        <p:spPr>
+          <a:xfrm>
+            <a:off x="10141202" y="5296995"/>
+            <a:ext cx="939627" cy="1238599"/>
           </a:xfrm>
           <a:prstGeom prst="rect">
             <a:avLst/>

</xml_diff>